<commit_message>
Changed icon of IAM service.
</commit_message>
<xml_diff>
--- a/docu/AWS-Architecture.pptx
+++ b/docu/AWS-Architecture.pptx
@@ -6763,10 +6763,10 @@
       </p:grpSp>
       <p:grpSp>
         <p:nvGrpSpPr>
-          <p:cNvPr id="61" name="Gruppieren 60">
-            <a:extLst>
-              <a:ext uri="{FF2B5EF4-FFF2-40B4-BE49-F238E27FC236}">
-                <a16:creationId xmlns:a16="http://schemas.microsoft.com/office/drawing/2014/main" id="{B890A991-6237-AB72-8C95-B90DDA1F0A14}"/>
+          <p:cNvPr id="41" name="Gruppieren 40">
+            <a:extLst>
+              <a:ext uri="{FF2B5EF4-FFF2-40B4-BE49-F238E27FC236}">
+                <a16:creationId xmlns:a16="http://schemas.microsoft.com/office/drawing/2014/main" id="{01C02EA5-E3D5-81A1-2314-385AE1BF554A}"/>
               </a:ext>
             </a:extLst>
           </p:cNvPr>
@@ -6775,331 +6775,98 @@
         </p:nvGrpSpPr>
         <p:grpSpPr>
           <a:xfrm>
-            <a:off x="5398166" y="1543315"/>
-            <a:ext cx="2441631" cy="1040114"/>
-            <a:chOff x="4476750" y="595995"/>
-            <a:chExt cx="2441631" cy="1040114"/>
+            <a:off x="5531272" y="1882656"/>
+            <a:ext cx="1193023" cy="616862"/>
+            <a:chOff x="3453540" y="4723571"/>
+            <a:chExt cx="1193023" cy="616862"/>
           </a:xfrm>
         </p:grpSpPr>
-        <p:grpSp>
-          <p:nvGrpSpPr>
-            <p:cNvPr id="41" name="Gruppieren 40">
+        <p:pic>
+          <p:nvPicPr>
+            <p:cNvPr id="21" name="Graphic 72" descr="Role resource icon for the IAM service.">
               <a:extLst>
                 <a:ext uri="{FF2B5EF4-FFF2-40B4-BE49-F238E27FC236}">
-                  <a16:creationId xmlns:a16="http://schemas.microsoft.com/office/drawing/2014/main" id="{01C02EA5-E3D5-81A1-2314-385AE1BF554A}"/>
+                  <a16:creationId xmlns:a16="http://schemas.microsoft.com/office/drawing/2014/main" id="{26677775-3154-4096-8694-4B7358F3D16C}"/>
                 </a:ext>
               </a:extLst>
             </p:cNvPr>
-            <p:cNvGrpSpPr/>
+            <p:cNvPicPr>
+              <a:picLocks noChangeAspect="1"/>
+            </p:cNvPicPr>
             <p:nvPr/>
-          </p:nvGrpSpPr>
-          <p:grpSpPr>
-            <a:xfrm>
-              <a:off x="4609856" y="935336"/>
-              <a:ext cx="1193023" cy="616862"/>
-              <a:chOff x="3453540" y="4723571"/>
-              <a:chExt cx="1193023" cy="616862"/>
-            </a:xfrm>
-          </p:grpSpPr>
-          <p:pic>
-            <p:nvPicPr>
-              <p:cNvPr id="21" name="Graphic 72" descr="Role resource icon for the IAM service.">
-                <a:extLst>
-                  <a:ext uri="{FF2B5EF4-FFF2-40B4-BE49-F238E27FC236}">
-                    <a16:creationId xmlns:a16="http://schemas.microsoft.com/office/drawing/2014/main" id="{26677775-3154-4096-8694-4B7358F3D16C}"/>
-                  </a:ext>
-                </a:extLst>
-              </p:cNvPr>
-              <p:cNvPicPr>
-                <a:picLocks noChangeAspect="1"/>
-              </p:cNvPicPr>
-              <p:nvPr/>
-            </p:nvPicPr>
-            <p:blipFill>
-              <a:blip r:embed="rId12">
-                <a:extLst>
-                  <a:ext uri="{96DAC541-7B7A-43D3-8B79-37D633B846F1}">
-                    <asvg:svgBlip xmlns:asvg="http://schemas.microsoft.com/office/drawing/2016/SVG/main" r:embed="rId13"/>
-                  </a:ext>
-                </a:extLst>
-              </a:blip>
-              <a:stretch>
-                <a:fillRect/>
-              </a:stretch>
-            </p:blipFill>
-            <p:spPr>
-              <a:xfrm>
-                <a:off x="3874432" y="4723571"/>
-                <a:ext cx="351241" cy="351241"/>
-              </a:xfrm>
-              <a:prstGeom prst="rect">
-                <a:avLst/>
-              </a:prstGeom>
-            </p:spPr>
-          </p:pic>
-          <p:sp>
-            <p:nvSpPr>
-              <p:cNvPr id="22" name="TextBox 29">
-                <a:extLst>
-                  <a:ext uri="{FF2B5EF4-FFF2-40B4-BE49-F238E27FC236}">
-                    <a16:creationId xmlns:a16="http://schemas.microsoft.com/office/drawing/2014/main" id="{0F02AB39-166A-4382-8A27-57908748AFED}"/>
-                  </a:ext>
-                </a:extLst>
-              </p:cNvPr>
-              <p:cNvSpPr txBox="1">
-                <a:spLocks noChangeArrowheads="1"/>
-              </p:cNvSpPr>
-              <p:nvPr/>
-            </p:nvSpPr>
-            <p:spPr bwMode="auto">
-              <a:xfrm>
-                <a:off x="3453540" y="5001879"/>
-                <a:ext cx="1193023" cy="338554"/>
-              </a:xfrm>
-              <a:prstGeom prst="rect">
-                <a:avLst/>
-              </a:prstGeom>
-              <a:noFill/>
-              <a:ln>
-                <a:noFill/>
-              </a:ln>
+          </p:nvPicPr>
+          <p:blipFill>
+            <a:blip r:embed="rId12">
               <a:extLst>
-                <a:ext uri="{909E8E84-426E-40DD-AFC4-6F175D3DCCD1}">
-                  <a14:hiddenFill xmlns:a14="http://schemas.microsoft.com/office/drawing/2010/main">
-                    <a:solidFill>
-                      <a:srgbClr val="FFFFFF"/>
-                    </a:solidFill>
-                  </a14:hiddenFill>
-                </a:ext>
-                <a:ext uri="{91240B29-F687-4F45-9708-019B960494DF}">
-                  <a14:hiddenLine xmlns:a14="http://schemas.microsoft.com/office/drawing/2010/main" w="9525">
-                    <a:solidFill>
-                      <a:srgbClr val="000000"/>
-                    </a:solidFill>
-                    <a:miter lim="800000"/>
-                    <a:headEnd/>
-                    <a:tailEnd/>
-                  </a14:hiddenLine>
+                <a:ext uri="{96DAC541-7B7A-43D3-8B79-37D633B846F1}">
+                  <asvg:svgBlip xmlns:asvg="http://schemas.microsoft.com/office/drawing/2016/SVG/main" r:embed="rId13"/>
                 </a:ext>
               </a:extLst>
-            </p:spPr>
-            <p:txBody>
-              <a:bodyPr wrap="square">
-                <a:spAutoFit/>
-              </a:bodyPr>
-              <a:lstStyle>
-                <a:defPPr>
-                  <a:defRPr lang="en-US"/>
-                </a:defPPr>
-                <a:lvl1pPr algn="l" rtl="0" eaLnBrk="0" fontAlgn="base" hangingPunct="0">
-                  <a:spcBef>
-                    <a:spcPct val="0"/>
-                  </a:spcBef>
-                  <a:spcAft>
-                    <a:spcPct val="0"/>
-                  </a:spcAft>
-                  <a:defRPr kern="1200">
-                    <a:solidFill>
-                      <a:schemeClr val="tx1"/>
-                    </a:solidFill>
-                    <a:latin typeface="Calibri" panose="020F0502020204030204" pitchFamily="34" charset="0"/>
-                    <a:ea typeface="+mn-ea"/>
-                    <a:cs typeface="+mn-cs"/>
-                  </a:defRPr>
-                </a:lvl1pPr>
-                <a:lvl2pPr marL="742950" indent="-285750" algn="l" rtl="0" eaLnBrk="0" fontAlgn="base" hangingPunct="0">
-                  <a:spcBef>
-                    <a:spcPct val="0"/>
-                  </a:spcBef>
-                  <a:spcAft>
-                    <a:spcPct val="0"/>
-                  </a:spcAft>
-                  <a:defRPr kern="1200">
-                    <a:solidFill>
-                      <a:schemeClr val="tx1"/>
-                    </a:solidFill>
-                    <a:latin typeface="Calibri" panose="020F0502020204030204" pitchFamily="34" charset="0"/>
-                    <a:ea typeface="+mn-ea"/>
-                    <a:cs typeface="+mn-cs"/>
-                  </a:defRPr>
-                </a:lvl2pPr>
-                <a:lvl3pPr marL="1143000" indent="-228600" algn="l" rtl="0" eaLnBrk="0" fontAlgn="base" hangingPunct="0">
-                  <a:spcBef>
-                    <a:spcPct val="0"/>
-                  </a:spcBef>
-                  <a:spcAft>
-                    <a:spcPct val="0"/>
-                  </a:spcAft>
-                  <a:defRPr kern="1200">
-                    <a:solidFill>
-                      <a:schemeClr val="tx1"/>
-                    </a:solidFill>
-                    <a:latin typeface="Calibri" panose="020F0502020204030204" pitchFamily="34" charset="0"/>
-                    <a:ea typeface="+mn-ea"/>
-                    <a:cs typeface="+mn-cs"/>
-                  </a:defRPr>
-                </a:lvl3pPr>
-                <a:lvl4pPr marL="1600200" indent="-228600" algn="l" rtl="0" eaLnBrk="0" fontAlgn="base" hangingPunct="0">
-                  <a:spcBef>
-                    <a:spcPct val="0"/>
-                  </a:spcBef>
-                  <a:spcAft>
-                    <a:spcPct val="0"/>
-                  </a:spcAft>
-                  <a:defRPr kern="1200">
-                    <a:solidFill>
-                      <a:schemeClr val="tx1"/>
-                    </a:solidFill>
-                    <a:latin typeface="Calibri" panose="020F0502020204030204" pitchFamily="34" charset="0"/>
-                    <a:ea typeface="+mn-ea"/>
-                    <a:cs typeface="+mn-cs"/>
-                  </a:defRPr>
-                </a:lvl4pPr>
-                <a:lvl5pPr marL="2057400" indent="-228600" algn="l" rtl="0" eaLnBrk="0" fontAlgn="base" hangingPunct="0">
-                  <a:spcBef>
-                    <a:spcPct val="0"/>
-                  </a:spcBef>
-                  <a:spcAft>
-                    <a:spcPct val="0"/>
-                  </a:spcAft>
-                  <a:defRPr kern="1200">
-                    <a:solidFill>
-                      <a:schemeClr val="tx1"/>
-                    </a:solidFill>
-                    <a:latin typeface="Calibri" panose="020F0502020204030204" pitchFamily="34" charset="0"/>
-                    <a:ea typeface="+mn-ea"/>
-                    <a:cs typeface="+mn-cs"/>
-                  </a:defRPr>
-                </a:lvl5pPr>
-                <a:lvl6pPr marL="2514600" indent="-228600" algn="l" defTabSz="914400" rtl="0" eaLnBrk="0" fontAlgn="base" latinLnBrk="0" hangingPunct="0">
-                  <a:spcBef>
-                    <a:spcPct val="0"/>
-                  </a:spcBef>
-                  <a:spcAft>
-                    <a:spcPct val="0"/>
-                  </a:spcAft>
-                  <a:defRPr kern="1200">
-                    <a:solidFill>
-                      <a:schemeClr val="tx1"/>
-                    </a:solidFill>
-                    <a:latin typeface="Calibri" panose="020F0502020204030204" pitchFamily="34" charset="0"/>
-                    <a:ea typeface="+mn-ea"/>
-                    <a:cs typeface="+mn-cs"/>
-                  </a:defRPr>
-                </a:lvl6pPr>
-                <a:lvl7pPr marL="2971800" indent="-228600" algn="l" defTabSz="914400" rtl="0" eaLnBrk="0" fontAlgn="base" latinLnBrk="0" hangingPunct="0">
-                  <a:spcBef>
-                    <a:spcPct val="0"/>
-                  </a:spcBef>
-                  <a:spcAft>
-                    <a:spcPct val="0"/>
-                  </a:spcAft>
-                  <a:defRPr kern="1200">
-                    <a:solidFill>
-                      <a:schemeClr val="tx1"/>
-                    </a:solidFill>
-                    <a:latin typeface="Calibri" panose="020F0502020204030204" pitchFamily="34" charset="0"/>
-                    <a:ea typeface="+mn-ea"/>
-                    <a:cs typeface="+mn-cs"/>
-                  </a:defRPr>
-                </a:lvl7pPr>
-                <a:lvl8pPr marL="3429000" indent="-228600" algn="l" defTabSz="914400" rtl="0" eaLnBrk="0" fontAlgn="base" latinLnBrk="0" hangingPunct="0">
-                  <a:spcBef>
-                    <a:spcPct val="0"/>
-                  </a:spcBef>
-                  <a:spcAft>
-                    <a:spcPct val="0"/>
-                  </a:spcAft>
-                  <a:defRPr kern="1200">
-                    <a:solidFill>
-                      <a:schemeClr val="tx1"/>
-                    </a:solidFill>
-                    <a:latin typeface="Calibri" panose="020F0502020204030204" pitchFamily="34" charset="0"/>
-                    <a:ea typeface="+mn-ea"/>
-                    <a:cs typeface="+mn-cs"/>
-                  </a:defRPr>
-                </a:lvl8pPr>
-                <a:lvl9pPr marL="3886200" indent="-228600" algn="l" defTabSz="914400" rtl="0" eaLnBrk="0" fontAlgn="base" latinLnBrk="0" hangingPunct="0">
-                  <a:spcBef>
-                    <a:spcPct val="0"/>
-                  </a:spcBef>
-                  <a:spcAft>
-                    <a:spcPct val="0"/>
-                  </a:spcAft>
-                  <a:defRPr kern="1200">
-                    <a:solidFill>
-                      <a:schemeClr val="tx1"/>
-                    </a:solidFill>
-                    <a:latin typeface="Calibri" panose="020F0502020204030204" pitchFamily="34" charset="0"/>
-                    <a:ea typeface="+mn-ea"/>
-                    <a:cs typeface="+mn-cs"/>
-                  </a:defRPr>
-                </a:lvl9pPr>
-              </a:lstStyle>
-              <a:p>
-                <a:pPr algn="ctr" eaLnBrk="1" hangingPunct="1"/>
-                <a:r>
-                  <a:rPr lang="en-US" altLang="en-US" sz="800" dirty="0" err="1">
-                    <a:latin typeface="Arial" panose="020B0604020202020204" pitchFamily="34" charset="0"/>
-                    <a:ea typeface="Amazon Ember" panose="020B0603020204020204" pitchFamily="34" charset="0"/>
-                    <a:cs typeface="Arial" panose="020B0604020202020204" pitchFamily="34" charset="0"/>
-                  </a:rPr>
-                  <a:t>DownloadUrlLambdaServiceRole</a:t>
-                </a:r>
-                <a:endParaRPr lang="en-US" altLang="en-US" sz="800" dirty="0">
-                  <a:latin typeface="Arial" panose="020B0604020202020204" pitchFamily="34" charset="0"/>
-                  <a:ea typeface="Amazon Ember" panose="020B0603020204020204" pitchFamily="34" charset="0"/>
-                  <a:cs typeface="Arial" panose="020B0604020202020204" pitchFamily="34" charset="0"/>
-                </a:endParaRPr>
-              </a:p>
-            </p:txBody>
-          </p:sp>
-        </p:grpSp>
+            </a:blip>
+            <a:stretch>
+              <a:fillRect/>
+            </a:stretch>
+          </p:blipFill>
+          <p:spPr>
+            <a:xfrm>
+              <a:off x="3874432" y="4723571"/>
+              <a:ext cx="351241" cy="351241"/>
+            </a:xfrm>
+            <a:prstGeom prst="rect">
+              <a:avLst/>
+            </a:prstGeom>
+          </p:spPr>
+        </p:pic>
         <p:sp>
           <p:nvSpPr>
-            <p:cNvPr id="38" name="Rectangle 62">
+            <p:cNvPr id="22" name="TextBox 29">
               <a:extLst>
                 <a:ext uri="{FF2B5EF4-FFF2-40B4-BE49-F238E27FC236}">
-                  <a16:creationId xmlns:a16="http://schemas.microsoft.com/office/drawing/2014/main" id="{08FA695D-70A0-4F41-8C21-E437C7B3DF77}"/>
+                  <a16:creationId xmlns:a16="http://schemas.microsoft.com/office/drawing/2014/main" id="{0F02AB39-166A-4382-8A27-57908748AFED}"/>
                 </a:ext>
               </a:extLst>
             </p:cNvPr>
-            <p:cNvSpPr/>
+            <p:cNvSpPr txBox="1">
+              <a:spLocks noChangeArrowheads="1"/>
+            </p:cNvSpPr>
             <p:nvPr/>
           </p:nvSpPr>
-          <p:spPr>
+          <p:spPr bwMode="auto">
             <a:xfrm>
-              <a:off x="4476750" y="595996"/>
-              <a:ext cx="2441631" cy="1040113"/>
+              <a:off x="3453540" y="5001879"/>
+              <a:ext cx="1193023" cy="338554"/>
             </a:xfrm>
             <a:prstGeom prst="rect">
               <a:avLst/>
             </a:prstGeom>
             <a:noFill/>
-            <a:ln w="15875">
-              <a:solidFill>
-                <a:srgbClr val="DD344C"/>
-              </a:solidFill>
+            <a:ln>
+              <a:noFill/>
             </a:ln>
+            <a:extLst>
+              <a:ext uri="{909E8E84-426E-40DD-AFC4-6F175D3DCCD1}">
+                <a14:hiddenFill xmlns:a14="http://schemas.microsoft.com/office/drawing/2010/main">
+                  <a:solidFill>
+                    <a:srgbClr val="FFFFFF"/>
+                  </a:solidFill>
+                </a14:hiddenFill>
+              </a:ext>
+              <a:ext uri="{91240B29-F687-4F45-9708-019B960494DF}">
+                <a14:hiddenLine xmlns:a14="http://schemas.microsoft.com/office/drawing/2010/main" w="9525">
+                  <a:solidFill>
+                    <a:srgbClr val="000000"/>
+                  </a:solidFill>
+                  <a:miter lim="800000"/>
+                  <a:headEnd/>
+                  <a:tailEnd/>
+                </a14:hiddenLine>
+              </a:ext>
+            </a:extLst>
           </p:spPr>
-          <p:style>
-            <a:lnRef idx="2">
-              <a:schemeClr val="accent1">
-                <a:shade val="50000"/>
-              </a:schemeClr>
-            </a:lnRef>
-            <a:fillRef idx="1">
-              <a:schemeClr val="accent1"/>
-            </a:fillRef>
-            <a:effectRef idx="0">
-              <a:schemeClr val="accent1"/>
-            </a:effectRef>
-            <a:fontRef idx="minor">
-              <a:schemeClr val="lt1"/>
-            </a:fontRef>
-          </p:style>
           <p:txBody>
-            <a:bodyPr lIns="502920" tIns="91440"/>
+            <a:bodyPr wrap="square">
+              <a:spAutoFit/>
+            </a:bodyPr>
             <a:lstStyle>
               <a:defPPr>
                 <a:defRPr lang="en-US"/>
@@ -7113,14 +6880,14 @@
                 </a:spcAft>
                 <a:defRPr kern="1200">
                   <a:solidFill>
-                    <a:schemeClr val="lt1"/>
+                    <a:schemeClr val="tx1"/>
                   </a:solidFill>
-                  <a:latin typeface="+mn-lt"/>
+                  <a:latin typeface="Calibri" panose="020F0502020204030204" pitchFamily="34" charset="0"/>
                   <a:ea typeface="+mn-ea"/>
                   <a:cs typeface="+mn-cs"/>
                 </a:defRPr>
               </a:lvl1pPr>
-              <a:lvl2pPr marL="457200" algn="l" rtl="0" eaLnBrk="0" fontAlgn="base" hangingPunct="0">
+              <a:lvl2pPr marL="742950" indent="-285750" algn="l" rtl="0" eaLnBrk="0" fontAlgn="base" hangingPunct="0">
                 <a:spcBef>
                   <a:spcPct val="0"/>
                 </a:spcBef>
@@ -7129,14 +6896,14 @@
                 </a:spcAft>
                 <a:defRPr kern="1200">
                   <a:solidFill>
-                    <a:schemeClr val="lt1"/>
+                    <a:schemeClr val="tx1"/>
                   </a:solidFill>
-                  <a:latin typeface="+mn-lt"/>
+                  <a:latin typeface="Calibri" panose="020F0502020204030204" pitchFamily="34" charset="0"/>
                   <a:ea typeface="+mn-ea"/>
                   <a:cs typeface="+mn-cs"/>
                 </a:defRPr>
               </a:lvl2pPr>
-              <a:lvl3pPr marL="914400" algn="l" rtl="0" eaLnBrk="0" fontAlgn="base" hangingPunct="0">
+              <a:lvl3pPr marL="1143000" indent="-228600" algn="l" rtl="0" eaLnBrk="0" fontAlgn="base" hangingPunct="0">
                 <a:spcBef>
                   <a:spcPct val="0"/>
                 </a:spcBef>
@@ -7145,14 +6912,14 @@
                 </a:spcAft>
                 <a:defRPr kern="1200">
                   <a:solidFill>
-                    <a:schemeClr val="lt1"/>
+                    <a:schemeClr val="tx1"/>
                   </a:solidFill>
-                  <a:latin typeface="+mn-lt"/>
+                  <a:latin typeface="Calibri" panose="020F0502020204030204" pitchFamily="34" charset="0"/>
                   <a:ea typeface="+mn-ea"/>
                   <a:cs typeface="+mn-cs"/>
                 </a:defRPr>
               </a:lvl3pPr>
-              <a:lvl4pPr marL="1371600" algn="l" rtl="0" eaLnBrk="0" fontAlgn="base" hangingPunct="0">
+              <a:lvl4pPr marL="1600200" indent="-228600" algn="l" rtl="0" eaLnBrk="0" fontAlgn="base" hangingPunct="0">
                 <a:spcBef>
                   <a:spcPct val="0"/>
                 </a:spcBef>
@@ -7161,14 +6928,14 @@
                 </a:spcAft>
                 <a:defRPr kern="1200">
                   <a:solidFill>
-                    <a:schemeClr val="lt1"/>
+                    <a:schemeClr val="tx1"/>
                   </a:solidFill>
-                  <a:latin typeface="+mn-lt"/>
+                  <a:latin typeface="Calibri" panose="020F0502020204030204" pitchFamily="34" charset="0"/>
                   <a:ea typeface="+mn-ea"/>
                   <a:cs typeface="+mn-cs"/>
                 </a:defRPr>
               </a:lvl4pPr>
-              <a:lvl5pPr marL="1828800" algn="l" rtl="0" eaLnBrk="0" fontAlgn="base" hangingPunct="0">
+              <a:lvl5pPr marL="2057400" indent="-228600" algn="l" rtl="0" eaLnBrk="0" fontAlgn="base" hangingPunct="0">
                 <a:spcBef>
                   <a:spcPct val="0"/>
                 </a:spcBef>
@@ -7177,83 +6944,351 @@
                 </a:spcAft>
                 <a:defRPr kern="1200">
                   <a:solidFill>
-                    <a:schemeClr val="lt1"/>
+                    <a:schemeClr val="tx1"/>
                   </a:solidFill>
-                  <a:latin typeface="+mn-lt"/>
+                  <a:latin typeface="Calibri" panose="020F0502020204030204" pitchFamily="34" charset="0"/>
                   <a:ea typeface="+mn-ea"/>
                   <a:cs typeface="+mn-cs"/>
                 </a:defRPr>
               </a:lvl5pPr>
-              <a:lvl6pPr marL="2286000" algn="l" defTabSz="914400" rtl="0" eaLnBrk="1" latinLnBrk="0" hangingPunct="1">
+              <a:lvl6pPr marL="2514600" indent="-228600" algn="l" defTabSz="914400" rtl="0" eaLnBrk="0" fontAlgn="base" latinLnBrk="0" hangingPunct="0">
+                <a:spcBef>
+                  <a:spcPct val="0"/>
+                </a:spcBef>
+                <a:spcAft>
+                  <a:spcPct val="0"/>
+                </a:spcAft>
                 <a:defRPr kern="1200">
                   <a:solidFill>
-                    <a:schemeClr val="lt1"/>
+                    <a:schemeClr val="tx1"/>
                   </a:solidFill>
-                  <a:latin typeface="+mn-lt"/>
+                  <a:latin typeface="Calibri" panose="020F0502020204030204" pitchFamily="34" charset="0"/>
                   <a:ea typeface="+mn-ea"/>
                   <a:cs typeface="+mn-cs"/>
                 </a:defRPr>
               </a:lvl6pPr>
-              <a:lvl7pPr marL="2743200" algn="l" defTabSz="914400" rtl="0" eaLnBrk="1" latinLnBrk="0" hangingPunct="1">
+              <a:lvl7pPr marL="2971800" indent="-228600" algn="l" defTabSz="914400" rtl="0" eaLnBrk="0" fontAlgn="base" latinLnBrk="0" hangingPunct="0">
+                <a:spcBef>
+                  <a:spcPct val="0"/>
+                </a:spcBef>
+                <a:spcAft>
+                  <a:spcPct val="0"/>
+                </a:spcAft>
                 <a:defRPr kern="1200">
                   <a:solidFill>
-                    <a:schemeClr val="lt1"/>
+                    <a:schemeClr val="tx1"/>
                   </a:solidFill>
-                  <a:latin typeface="+mn-lt"/>
+                  <a:latin typeface="Calibri" panose="020F0502020204030204" pitchFamily="34" charset="0"/>
                   <a:ea typeface="+mn-ea"/>
                   <a:cs typeface="+mn-cs"/>
                 </a:defRPr>
               </a:lvl7pPr>
-              <a:lvl8pPr marL="3200400" algn="l" defTabSz="914400" rtl="0" eaLnBrk="1" latinLnBrk="0" hangingPunct="1">
+              <a:lvl8pPr marL="3429000" indent="-228600" algn="l" defTabSz="914400" rtl="0" eaLnBrk="0" fontAlgn="base" latinLnBrk="0" hangingPunct="0">
+                <a:spcBef>
+                  <a:spcPct val="0"/>
+                </a:spcBef>
+                <a:spcAft>
+                  <a:spcPct val="0"/>
+                </a:spcAft>
                 <a:defRPr kern="1200">
                   <a:solidFill>
-                    <a:schemeClr val="lt1"/>
+                    <a:schemeClr val="tx1"/>
                   </a:solidFill>
-                  <a:latin typeface="+mn-lt"/>
+                  <a:latin typeface="Calibri" panose="020F0502020204030204" pitchFamily="34" charset="0"/>
                   <a:ea typeface="+mn-ea"/>
                   <a:cs typeface="+mn-cs"/>
                 </a:defRPr>
               </a:lvl8pPr>
-              <a:lvl9pPr marL="3657600" algn="l" defTabSz="914400" rtl="0" eaLnBrk="1" latinLnBrk="0" hangingPunct="1">
+              <a:lvl9pPr marL="3886200" indent="-228600" algn="l" defTabSz="914400" rtl="0" eaLnBrk="0" fontAlgn="base" latinLnBrk="0" hangingPunct="0">
+                <a:spcBef>
+                  <a:spcPct val="0"/>
+                </a:spcBef>
+                <a:spcAft>
+                  <a:spcPct val="0"/>
+                </a:spcAft>
                 <a:defRPr kern="1200">
                   <a:solidFill>
-                    <a:schemeClr val="lt1"/>
+                    <a:schemeClr val="tx1"/>
                   </a:solidFill>
-                  <a:latin typeface="+mn-lt"/>
+                  <a:latin typeface="Calibri" panose="020F0502020204030204" pitchFamily="34" charset="0"/>
                   <a:ea typeface="+mn-ea"/>
                   <a:cs typeface="+mn-cs"/>
                 </a:defRPr>
               </a:lvl9pPr>
             </a:lstStyle>
             <a:p>
-              <a:pPr eaLnBrk="1" fontAlgn="auto" hangingPunct="1">
-                <a:spcBef>
-                  <a:spcPts val="0"/>
-                </a:spcBef>
-                <a:spcAft>
-                  <a:spcPts val="0"/>
-                </a:spcAft>
-                <a:defRPr/>
-              </a:pPr>
+              <a:pPr algn="ctr" eaLnBrk="1" hangingPunct="1"/>
               <a:r>
-                <a:rPr lang="en-US" sz="800" dirty="0">
-                  <a:solidFill>
-                    <a:schemeClr val="tx1"/>
-                  </a:solidFill>
+                <a:rPr lang="en-US" altLang="en-US" sz="800" dirty="0" err="1">
                   <a:latin typeface="Arial" panose="020B0604020202020204" pitchFamily="34" charset="0"/>
+                  <a:ea typeface="Amazon Ember" panose="020B0603020204020204" pitchFamily="34" charset="0"/>
                   <a:cs typeface="Arial" panose="020B0604020202020204" pitchFamily="34" charset="0"/>
                 </a:rPr>
-                <a:t>AWS IAM Identity Center</a:t>
+                <a:t>DownloadUrlLambdaServiceRole</a:t>
               </a:r>
+              <a:endParaRPr lang="en-US" altLang="en-US" sz="800" dirty="0">
+                <a:latin typeface="Arial" panose="020B0604020202020204" pitchFamily="34" charset="0"/>
+                <a:ea typeface="Amazon Ember" panose="020B0603020204020204" pitchFamily="34" charset="0"/>
+                <a:cs typeface="Arial" panose="020B0604020202020204" pitchFamily="34" charset="0"/>
+              </a:endParaRPr>
             </a:p>
           </p:txBody>
         </p:sp>
+      </p:grpSp>
+      <p:sp>
+        <p:nvSpPr>
+          <p:cNvPr id="38" name="Rectangle 62">
+            <a:extLst>
+              <a:ext uri="{FF2B5EF4-FFF2-40B4-BE49-F238E27FC236}">
+                <a16:creationId xmlns:a16="http://schemas.microsoft.com/office/drawing/2014/main" id="{08FA695D-70A0-4F41-8C21-E437C7B3DF77}"/>
+              </a:ext>
+            </a:extLst>
+          </p:cNvPr>
+          <p:cNvSpPr/>
+          <p:nvPr/>
+        </p:nvSpPr>
+        <p:spPr>
+          <a:xfrm>
+            <a:off x="5398166" y="1543316"/>
+            <a:ext cx="2441631" cy="1040113"/>
+          </a:xfrm>
+          <a:prstGeom prst="rect">
+            <a:avLst/>
+          </a:prstGeom>
+          <a:noFill/>
+          <a:ln w="15875">
+            <a:solidFill>
+              <a:srgbClr val="DD344C"/>
+            </a:solidFill>
+          </a:ln>
+        </p:spPr>
+        <p:style>
+          <a:lnRef idx="2">
+            <a:schemeClr val="accent1">
+              <a:shade val="50000"/>
+            </a:schemeClr>
+          </a:lnRef>
+          <a:fillRef idx="1">
+            <a:schemeClr val="accent1"/>
+          </a:fillRef>
+          <a:effectRef idx="0">
+            <a:schemeClr val="accent1"/>
+          </a:effectRef>
+          <a:fontRef idx="minor">
+            <a:schemeClr val="lt1"/>
+          </a:fontRef>
+        </p:style>
+        <p:txBody>
+          <a:bodyPr lIns="502920" tIns="91440"/>
+          <a:lstStyle>
+            <a:defPPr>
+              <a:defRPr lang="en-US"/>
+            </a:defPPr>
+            <a:lvl1pPr algn="l" rtl="0" eaLnBrk="0" fontAlgn="base" hangingPunct="0">
+              <a:spcBef>
+                <a:spcPct val="0"/>
+              </a:spcBef>
+              <a:spcAft>
+                <a:spcPct val="0"/>
+              </a:spcAft>
+              <a:defRPr kern="1200">
+                <a:solidFill>
+                  <a:schemeClr val="lt1"/>
+                </a:solidFill>
+                <a:latin typeface="+mn-lt"/>
+                <a:ea typeface="+mn-ea"/>
+                <a:cs typeface="+mn-cs"/>
+              </a:defRPr>
+            </a:lvl1pPr>
+            <a:lvl2pPr marL="457200" algn="l" rtl="0" eaLnBrk="0" fontAlgn="base" hangingPunct="0">
+              <a:spcBef>
+                <a:spcPct val="0"/>
+              </a:spcBef>
+              <a:spcAft>
+                <a:spcPct val="0"/>
+              </a:spcAft>
+              <a:defRPr kern="1200">
+                <a:solidFill>
+                  <a:schemeClr val="lt1"/>
+                </a:solidFill>
+                <a:latin typeface="+mn-lt"/>
+                <a:ea typeface="+mn-ea"/>
+                <a:cs typeface="+mn-cs"/>
+              </a:defRPr>
+            </a:lvl2pPr>
+            <a:lvl3pPr marL="914400" algn="l" rtl="0" eaLnBrk="0" fontAlgn="base" hangingPunct="0">
+              <a:spcBef>
+                <a:spcPct val="0"/>
+              </a:spcBef>
+              <a:spcAft>
+                <a:spcPct val="0"/>
+              </a:spcAft>
+              <a:defRPr kern="1200">
+                <a:solidFill>
+                  <a:schemeClr val="lt1"/>
+                </a:solidFill>
+                <a:latin typeface="+mn-lt"/>
+                <a:ea typeface="+mn-ea"/>
+                <a:cs typeface="+mn-cs"/>
+              </a:defRPr>
+            </a:lvl3pPr>
+            <a:lvl4pPr marL="1371600" algn="l" rtl="0" eaLnBrk="0" fontAlgn="base" hangingPunct="0">
+              <a:spcBef>
+                <a:spcPct val="0"/>
+              </a:spcBef>
+              <a:spcAft>
+                <a:spcPct val="0"/>
+              </a:spcAft>
+              <a:defRPr kern="1200">
+                <a:solidFill>
+                  <a:schemeClr val="lt1"/>
+                </a:solidFill>
+                <a:latin typeface="+mn-lt"/>
+                <a:ea typeface="+mn-ea"/>
+                <a:cs typeface="+mn-cs"/>
+              </a:defRPr>
+            </a:lvl4pPr>
+            <a:lvl5pPr marL="1828800" algn="l" rtl="0" eaLnBrk="0" fontAlgn="base" hangingPunct="0">
+              <a:spcBef>
+                <a:spcPct val="0"/>
+              </a:spcBef>
+              <a:spcAft>
+                <a:spcPct val="0"/>
+              </a:spcAft>
+              <a:defRPr kern="1200">
+                <a:solidFill>
+                  <a:schemeClr val="lt1"/>
+                </a:solidFill>
+                <a:latin typeface="+mn-lt"/>
+                <a:ea typeface="+mn-ea"/>
+                <a:cs typeface="+mn-cs"/>
+              </a:defRPr>
+            </a:lvl5pPr>
+            <a:lvl6pPr marL="2286000" algn="l" defTabSz="914400" rtl="0" eaLnBrk="1" latinLnBrk="0" hangingPunct="1">
+              <a:defRPr kern="1200">
+                <a:solidFill>
+                  <a:schemeClr val="lt1"/>
+                </a:solidFill>
+                <a:latin typeface="+mn-lt"/>
+                <a:ea typeface="+mn-ea"/>
+                <a:cs typeface="+mn-cs"/>
+              </a:defRPr>
+            </a:lvl6pPr>
+            <a:lvl7pPr marL="2743200" algn="l" defTabSz="914400" rtl="0" eaLnBrk="1" latinLnBrk="0" hangingPunct="1">
+              <a:defRPr kern="1200">
+                <a:solidFill>
+                  <a:schemeClr val="lt1"/>
+                </a:solidFill>
+                <a:latin typeface="+mn-lt"/>
+                <a:ea typeface="+mn-ea"/>
+                <a:cs typeface="+mn-cs"/>
+              </a:defRPr>
+            </a:lvl7pPr>
+            <a:lvl8pPr marL="3200400" algn="l" defTabSz="914400" rtl="0" eaLnBrk="1" latinLnBrk="0" hangingPunct="1">
+              <a:defRPr kern="1200">
+                <a:solidFill>
+                  <a:schemeClr val="lt1"/>
+                </a:solidFill>
+                <a:latin typeface="+mn-lt"/>
+                <a:ea typeface="+mn-ea"/>
+                <a:cs typeface="+mn-cs"/>
+              </a:defRPr>
+            </a:lvl8pPr>
+            <a:lvl9pPr marL="3657600" algn="l" defTabSz="914400" rtl="0" eaLnBrk="1" latinLnBrk="0" hangingPunct="1">
+              <a:defRPr kern="1200">
+                <a:solidFill>
+                  <a:schemeClr val="lt1"/>
+                </a:solidFill>
+                <a:latin typeface="+mn-lt"/>
+                <a:ea typeface="+mn-ea"/>
+                <a:cs typeface="+mn-cs"/>
+              </a:defRPr>
+            </a:lvl9pPr>
+          </a:lstStyle>
+          <a:p>
+            <a:pPr eaLnBrk="1" fontAlgn="auto" hangingPunct="1">
+              <a:spcBef>
+                <a:spcPts val="0"/>
+              </a:spcBef>
+              <a:spcAft>
+                <a:spcPts val="0"/>
+              </a:spcAft>
+              <a:defRPr/>
+            </a:pPr>
+            <a:r>
+              <a:rPr lang="en-US" sz="800" dirty="0">
+                <a:solidFill>
+                  <a:schemeClr val="tx1"/>
+                </a:solidFill>
+                <a:latin typeface="Arial" panose="020B0604020202020204" pitchFamily="34" charset="0"/>
+                <a:cs typeface="Arial" panose="020B0604020202020204" pitchFamily="34" charset="0"/>
+              </a:rPr>
+              <a:t>AWS IAM Identity Center</a:t>
+            </a:r>
+          </a:p>
+        </p:txBody>
+      </p:sp>
+      <p:pic>
+        <p:nvPicPr>
+          <p:cNvPr id="39" name="Graphic 63">
+            <a:extLst>
+              <a:ext uri="{FF2B5EF4-FFF2-40B4-BE49-F238E27FC236}">
+                <a16:creationId xmlns:a16="http://schemas.microsoft.com/office/drawing/2014/main" id="{DA91B879-1EA9-4070-9829-D532FB7C5879}"/>
+              </a:ext>
+            </a:extLst>
+          </p:cNvPr>
+          <p:cNvPicPr>
+            <a:picLocks noChangeAspect="1"/>
+          </p:cNvPicPr>
+          <p:nvPr/>
+        </p:nvPicPr>
+        <p:blipFill>
+          <a:blip r:embed="rId14">
+            <a:extLst>
+              <a:ext uri="{96DAC541-7B7A-43D3-8B79-37D633B846F1}">
+                <asvg:svgBlip xmlns:asvg="http://schemas.microsoft.com/office/drawing/2016/SVG/main" r:embed="rId15"/>
+              </a:ext>
+            </a:extLst>
+          </a:blip>
+          <a:srcRect/>
+          <a:stretch/>
+        </p:blipFill>
+        <p:spPr>
+          <a:xfrm>
+            <a:off x="5398166" y="1543315"/>
+            <a:ext cx="381000" cy="381000"/>
+          </a:xfrm>
+          <a:prstGeom prst="rect">
+            <a:avLst/>
+          </a:prstGeom>
+        </p:spPr>
+      </p:pic>
+      <p:grpSp>
+        <p:nvGrpSpPr>
+          <p:cNvPr id="45" name="Gruppieren 44">
+            <a:extLst>
+              <a:ext uri="{FF2B5EF4-FFF2-40B4-BE49-F238E27FC236}">
+                <a16:creationId xmlns:a16="http://schemas.microsoft.com/office/drawing/2014/main" id="{5B9BD941-FB5E-E6CF-B177-B629323F1CDD}"/>
+              </a:ext>
+            </a:extLst>
+          </p:cNvPr>
+          <p:cNvGrpSpPr/>
+          <p:nvPr/>
+        </p:nvGrpSpPr>
+        <p:grpSpPr>
+          <a:xfrm>
+            <a:off x="6564942" y="1890747"/>
+            <a:ext cx="1049776" cy="615553"/>
+            <a:chOff x="3515874" y="4723571"/>
+            <a:chExt cx="1049776" cy="615553"/>
+          </a:xfrm>
+        </p:grpSpPr>
         <p:pic>
           <p:nvPicPr>
-            <p:cNvPr id="39" name="Graphic 63">
+            <p:cNvPr id="46" name="Graphic 72" descr="Role resource icon for the IAM service.">
               <a:extLst>
                 <a:ext uri="{FF2B5EF4-FFF2-40B4-BE49-F238E27FC236}">
-                  <a16:creationId xmlns:a16="http://schemas.microsoft.com/office/drawing/2014/main" id="{DA91B879-1EA9-4070-9829-D532FB7C5879}"/>
+                  <a16:creationId xmlns:a16="http://schemas.microsoft.com/office/drawing/2014/main" id="{F141BCE7-678C-12BD-1C4F-44B955D134AB}"/>
                 </a:ext>
               </a:extLst>
             </p:cNvPr>
@@ -7263,300 +7298,244 @@
             <p:nvPr/>
           </p:nvPicPr>
           <p:blipFill>
-            <a:blip r:embed="rId14">
+            <a:blip r:embed="rId12">
               <a:extLst>
-                <a:ext uri="{28A0092B-C50C-407E-A947-70E740481C1C}">
-                  <a14:useLocalDpi xmlns:a14="http://schemas.microsoft.com/office/drawing/2010/main" val="0"/>
+                <a:ext uri="{96DAC541-7B7A-43D3-8B79-37D633B846F1}">
+                  <asvg:svgBlip xmlns:asvg="http://schemas.microsoft.com/office/drawing/2016/SVG/main" r:embed="rId13"/>
                 </a:ext>
               </a:extLst>
             </a:blip>
-            <a:srcRect/>
-            <a:stretch/>
+            <a:stretch>
+              <a:fillRect/>
+            </a:stretch>
           </p:blipFill>
           <p:spPr>
             <a:xfrm>
-              <a:off x="4476750" y="595995"/>
-              <a:ext cx="381000" cy="381000"/>
+              <a:off x="3874432" y="4723571"/>
+              <a:ext cx="351241" cy="351241"/>
             </a:xfrm>
             <a:prstGeom prst="rect">
               <a:avLst/>
             </a:prstGeom>
           </p:spPr>
         </p:pic>
-        <p:grpSp>
-          <p:nvGrpSpPr>
-            <p:cNvPr id="45" name="Gruppieren 44">
+        <p:sp>
+          <p:nvSpPr>
+            <p:cNvPr id="47" name="TextBox 29">
               <a:extLst>
                 <a:ext uri="{FF2B5EF4-FFF2-40B4-BE49-F238E27FC236}">
-                  <a16:creationId xmlns:a16="http://schemas.microsoft.com/office/drawing/2014/main" id="{5B9BD941-FB5E-E6CF-B177-B629323F1CDD}"/>
+                  <a16:creationId xmlns:a16="http://schemas.microsoft.com/office/drawing/2014/main" id="{08E4E134-0D52-72C9-AE76-C4C6BCA5C49C}"/>
                 </a:ext>
               </a:extLst>
             </p:cNvPr>
-            <p:cNvGrpSpPr/>
+            <p:cNvSpPr txBox="1">
+              <a:spLocks noChangeArrowheads="1"/>
+            </p:cNvSpPr>
             <p:nvPr/>
-          </p:nvGrpSpPr>
-          <p:grpSpPr>
+          </p:nvSpPr>
+          <p:spPr bwMode="auto">
             <a:xfrm>
-              <a:off x="5643526" y="943427"/>
-              <a:ext cx="1049776" cy="615553"/>
-              <a:chOff x="3515874" y="4723571"/>
-              <a:chExt cx="1049776" cy="615553"/>
+              <a:off x="3515874" y="5000570"/>
+              <a:ext cx="1049776" cy="338554"/>
             </a:xfrm>
-          </p:grpSpPr>
-          <p:pic>
-            <p:nvPicPr>
-              <p:cNvPr id="46" name="Graphic 72" descr="Role resource icon for the IAM service.">
-                <a:extLst>
-                  <a:ext uri="{FF2B5EF4-FFF2-40B4-BE49-F238E27FC236}">
-                    <a16:creationId xmlns:a16="http://schemas.microsoft.com/office/drawing/2014/main" id="{F141BCE7-678C-12BD-1C4F-44B955D134AB}"/>
-                  </a:ext>
-                </a:extLst>
-              </p:cNvPr>
-              <p:cNvPicPr>
-                <a:picLocks noChangeAspect="1"/>
-              </p:cNvPicPr>
-              <p:nvPr/>
-            </p:nvPicPr>
-            <p:blipFill>
-              <a:blip r:embed="rId12">
-                <a:extLst>
-                  <a:ext uri="{96DAC541-7B7A-43D3-8B79-37D633B846F1}">
-                    <asvg:svgBlip xmlns:asvg="http://schemas.microsoft.com/office/drawing/2016/SVG/main" r:embed="rId13"/>
-                  </a:ext>
-                </a:extLst>
-              </a:blip>
-              <a:stretch>
-                <a:fillRect/>
-              </a:stretch>
-            </p:blipFill>
-            <p:spPr>
-              <a:xfrm>
-                <a:off x="3874432" y="4723571"/>
-                <a:ext cx="351241" cy="351241"/>
-              </a:xfrm>
-              <a:prstGeom prst="rect">
-                <a:avLst/>
-              </a:prstGeom>
-            </p:spPr>
-          </p:pic>
-          <p:sp>
-            <p:nvSpPr>
-              <p:cNvPr id="47" name="TextBox 29">
-                <a:extLst>
-                  <a:ext uri="{FF2B5EF4-FFF2-40B4-BE49-F238E27FC236}">
-                    <a16:creationId xmlns:a16="http://schemas.microsoft.com/office/drawing/2014/main" id="{08E4E134-0D52-72C9-AE76-C4C6BCA5C49C}"/>
-                  </a:ext>
-                </a:extLst>
-              </p:cNvPr>
-              <p:cNvSpPr txBox="1">
-                <a:spLocks noChangeArrowheads="1"/>
-              </p:cNvSpPr>
-              <p:nvPr/>
-            </p:nvSpPr>
-            <p:spPr bwMode="auto">
-              <a:xfrm>
-                <a:off x="3515874" y="5000570"/>
-                <a:ext cx="1049776" cy="338554"/>
-              </a:xfrm>
-              <a:prstGeom prst="rect">
-                <a:avLst/>
-              </a:prstGeom>
+            <a:prstGeom prst="rect">
+              <a:avLst/>
+            </a:prstGeom>
+            <a:noFill/>
+            <a:ln>
               <a:noFill/>
-              <a:ln>
-                <a:noFill/>
-              </a:ln>
-              <a:extLst>
-                <a:ext uri="{909E8E84-426E-40DD-AFC4-6F175D3DCCD1}">
-                  <a14:hiddenFill xmlns:a14="http://schemas.microsoft.com/office/drawing/2010/main">
-                    <a:solidFill>
-                      <a:srgbClr val="FFFFFF"/>
-                    </a:solidFill>
-                  </a14:hiddenFill>
-                </a:ext>
-                <a:ext uri="{91240B29-F687-4F45-9708-019B960494DF}">
-                  <a14:hiddenLine xmlns:a14="http://schemas.microsoft.com/office/drawing/2010/main" w="9525">
-                    <a:solidFill>
-                      <a:srgbClr val="000000"/>
-                    </a:solidFill>
-                    <a:miter lim="800000"/>
-                    <a:headEnd/>
-                    <a:tailEnd/>
-                  </a14:hiddenLine>
-                </a:ext>
-              </a:extLst>
-            </p:spPr>
-            <p:txBody>
-              <a:bodyPr wrap="square">
-                <a:spAutoFit/>
-              </a:bodyPr>
-              <a:lstStyle>
-                <a:defPPr>
-                  <a:defRPr lang="en-US"/>
-                </a:defPPr>
-                <a:lvl1pPr algn="l" rtl="0" eaLnBrk="0" fontAlgn="base" hangingPunct="0">
-                  <a:spcBef>
-                    <a:spcPct val="0"/>
-                  </a:spcBef>
-                  <a:spcAft>
-                    <a:spcPct val="0"/>
-                  </a:spcAft>
-                  <a:defRPr kern="1200">
-                    <a:solidFill>
-                      <a:schemeClr val="tx1"/>
-                    </a:solidFill>
-                    <a:latin typeface="Calibri" panose="020F0502020204030204" pitchFamily="34" charset="0"/>
-                    <a:ea typeface="+mn-ea"/>
-                    <a:cs typeface="+mn-cs"/>
-                  </a:defRPr>
-                </a:lvl1pPr>
-                <a:lvl2pPr marL="742950" indent="-285750" algn="l" rtl="0" eaLnBrk="0" fontAlgn="base" hangingPunct="0">
-                  <a:spcBef>
-                    <a:spcPct val="0"/>
-                  </a:spcBef>
-                  <a:spcAft>
-                    <a:spcPct val="0"/>
-                  </a:spcAft>
-                  <a:defRPr kern="1200">
-                    <a:solidFill>
-                      <a:schemeClr val="tx1"/>
-                    </a:solidFill>
-                    <a:latin typeface="Calibri" panose="020F0502020204030204" pitchFamily="34" charset="0"/>
-                    <a:ea typeface="+mn-ea"/>
-                    <a:cs typeface="+mn-cs"/>
-                  </a:defRPr>
-                </a:lvl2pPr>
-                <a:lvl3pPr marL="1143000" indent="-228600" algn="l" rtl="0" eaLnBrk="0" fontAlgn="base" hangingPunct="0">
-                  <a:spcBef>
-                    <a:spcPct val="0"/>
-                  </a:spcBef>
-                  <a:spcAft>
-                    <a:spcPct val="0"/>
-                  </a:spcAft>
-                  <a:defRPr kern="1200">
-                    <a:solidFill>
-                      <a:schemeClr val="tx1"/>
-                    </a:solidFill>
-                    <a:latin typeface="Calibri" panose="020F0502020204030204" pitchFamily="34" charset="0"/>
-                    <a:ea typeface="+mn-ea"/>
-                    <a:cs typeface="+mn-cs"/>
-                  </a:defRPr>
-                </a:lvl3pPr>
-                <a:lvl4pPr marL="1600200" indent="-228600" algn="l" rtl="0" eaLnBrk="0" fontAlgn="base" hangingPunct="0">
-                  <a:spcBef>
-                    <a:spcPct val="0"/>
-                  </a:spcBef>
-                  <a:spcAft>
-                    <a:spcPct val="0"/>
-                  </a:spcAft>
-                  <a:defRPr kern="1200">
-                    <a:solidFill>
-                      <a:schemeClr val="tx1"/>
-                    </a:solidFill>
-                    <a:latin typeface="Calibri" panose="020F0502020204030204" pitchFamily="34" charset="0"/>
-                    <a:ea typeface="+mn-ea"/>
-                    <a:cs typeface="+mn-cs"/>
-                  </a:defRPr>
-                </a:lvl4pPr>
-                <a:lvl5pPr marL="2057400" indent="-228600" algn="l" rtl="0" eaLnBrk="0" fontAlgn="base" hangingPunct="0">
-                  <a:spcBef>
-                    <a:spcPct val="0"/>
-                  </a:spcBef>
-                  <a:spcAft>
-                    <a:spcPct val="0"/>
-                  </a:spcAft>
-                  <a:defRPr kern="1200">
-                    <a:solidFill>
-                      <a:schemeClr val="tx1"/>
-                    </a:solidFill>
-                    <a:latin typeface="Calibri" panose="020F0502020204030204" pitchFamily="34" charset="0"/>
-                    <a:ea typeface="+mn-ea"/>
-                    <a:cs typeface="+mn-cs"/>
-                  </a:defRPr>
-                </a:lvl5pPr>
-                <a:lvl6pPr marL="2514600" indent="-228600" algn="l" defTabSz="914400" rtl="0" eaLnBrk="0" fontAlgn="base" latinLnBrk="0" hangingPunct="0">
-                  <a:spcBef>
-                    <a:spcPct val="0"/>
-                  </a:spcBef>
-                  <a:spcAft>
-                    <a:spcPct val="0"/>
-                  </a:spcAft>
-                  <a:defRPr kern="1200">
-                    <a:solidFill>
-                      <a:schemeClr val="tx1"/>
-                    </a:solidFill>
-                    <a:latin typeface="Calibri" panose="020F0502020204030204" pitchFamily="34" charset="0"/>
-                    <a:ea typeface="+mn-ea"/>
-                    <a:cs typeface="+mn-cs"/>
-                  </a:defRPr>
-                </a:lvl6pPr>
-                <a:lvl7pPr marL="2971800" indent="-228600" algn="l" defTabSz="914400" rtl="0" eaLnBrk="0" fontAlgn="base" latinLnBrk="0" hangingPunct="0">
-                  <a:spcBef>
-                    <a:spcPct val="0"/>
-                  </a:spcBef>
-                  <a:spcAft>
-                    <a:spcPct val="0"/>
-                  </a:spcAft>
-                  <a:defRPr kern="1200">
-                    <a:solidFill>
-                      <a:schemeClr val="tx1"/>
-                    </a:solidFill>
-                    <a:latin typeface="Calibri" panose="020F0502020204030204" pitchFamily="34" charset="0"/>
-                    <a:ea typeface="+mn-ea"/>
-                    <a:cs typeface="+mn-cs"/>
-                  </a:defRPr>
-                </a:lvl7pPr>
-                <a:lvl8pPr marL="3429000" indent="-228600" algn="l" defTabSz="914400" rtl="0" eaLnBrk="0" fontAlgn="base" latinLnBrk="0" hangingPunct="0">
-                  <a:spcBef>
-                    <a:spcPct val="0"/>
-                  </a:spcBef>
-                  <a:spcAft>
-                    <a:spcPct val="0"/>
-                  </a:spcAft>
-                  <a:defRPr kern="1200">
-                    <a:solidFill>
-                      <a:schemeClr val="tx1"/>
-                    </a:solidFill>
-                    <a:latin typeface="Calibri" panose="020F0502020204030204" pitchFamily="34" charset="0"/>
-                    <a:ea typeface="+mn-ea"/>
-                    <a:cs typeface="+mn-cs"/>
-                  </a:defRPr>
-                </a:lvl8pPr>
-                <a:lvl9pPr marL="3886200" indent="-228600" algn="l" defTabSz="914400" rtl="0" eaLnBrk="0" fontAlgn="base" latinLnBrk="0" hangingPunct="0">
-                  <a:spcBef>
-                    <a:spcPct val="0"/>
-                  </a:spcBef>
-                  <a:spcAft>
-                    <a:spcPct val="0"/>
-                  </a:spcAft>
-                  <a:defRPr kern="1200">
-                    <a:solidFill>
-                      <a:schemeClr val="tx1"/>
-                    </a:solidFill>
-                    <a:latin typeface="Calibri" panose="020F0502020204030204" pitchFamily="34" charset="0"/>
-                    <a:ea typeface="+mn-ea"/>
-                    <a:cs typeface="+mn-cs"/>
-                  </a:defRPr>
-                </a:lvl9pPr>
-              </a:lstStyle>
-              <a:p>
-                <a:pPr algn="ctr" eaLnBrk="1" hangingPunct="1"/>
-                <a:r>
-                  <a:rPr lang="en-US" altLang="en-US" sz="800" dirty="0" err="1">
-                    <a:latin typeface="Arial" panose="020B0604020202020204" pitchFamily="34" charset="0"/>
-                    <a:ea typeface="Amazon Ember" panose="020B0603020204020204" pitchFamily="34" charset="0"/>
-                    <a:cs typeface="Arial" panose="020B0604020202020204" pitchFamily="34" charset="0"/>
-                  </a:rPr>
-                  <a:t>UploadUrlLambdaServiceRole</a:t>
-                </a:r>
-                <a:endParaRPr lang="en-US" altLang="en-US" sz="800" dirty="0">
+            </a:ln>
+            <a:extLst>
+              <a:ext uri="{909E8E84-426E-40DD-AFC4-6F175D3DCCD1}">
+                <a14:hiddenFill xmlns:a14="http://schemas.microsoft.com/office/drawing/2010/main">
+                  <a:solidFill>
+                    <a:srgbClr val="FFFFFF"/>
+                  </a:solidFill>
+                </a14:hiddenFill>
+              </a:ext>
+              <a:ext uri="{91240B29-F687-4F45-9708-019B960494DF}">
+                <a14:hiddenLine xmlns:a14="http://schemas.microsoft.com/office/drawing/2010/main" w="9525">
+                  <a:solidFill>
+                    <a:srgbClr val="000000"/>
+                  </a:solidFill>
+                  <a:miter lim="800000"/>
+                  <a:headEnd/>
+                  <a:tailEnd/>
+                </a14:hiddenLine>
+              </a:ext>
+            </a:extLst>
+          </p:spPr>
+          <p:txBody>
+            <a:bodyPr wrap="square">
+              <a:spAutoFit/>
+            </a:bodyPr>
+            <a:lstStyle>
+              <a:defPPr>
+                <a:defRPr lang="en-US"/>
+              </a:defPPr>
+              <a:lvl1pPr algn="l" rtl="0" eaLnBrk="0" fontAlgn="base" hangingPunct="0">
+                <a:spcBef>
+                  <a:spcPct val="0"/>
+                </a:spcBef>
+                <a:spcAft>
+                  <a:spcPct val="0"/>
+                </a:spcAft>
+                <a:defRPr kern="1200">
+                  <a:solidFill>
+                    <a:schemeClr val="tx1"/>
+                  </a:solidFill>
+                  <a:latin typeface="Calibri" panose="020F0502020204030204" pitchFamily="34" charset="0"/>
+                  <a:ea typeface="+mn-ea"/>
+                  <a:cs typeface="+mn-cs"/>
+                </a:defRPr>
+              </a:lvl1pPr>
+              <a:lvl2pPr marL="742950" indent="-285750" algn="l" rtl="0" eaLnBrk="0" fontAlgn="base" hangingPunct="0">
+                <a:spcBef>
+                  <a:spcPct val="0"/>
+                </a:spcBef>
+                <a:spcAft>
+                  <a:spcPct val="0"/>
+                </a:spcAft>
+                <a:defRPr kern="1200">
+                  <a:solidFill>
+                    <a:schemeClr val="tx1"/>
+                  </a:solidFill>
+                  <a:latin typeface="Calibri" panose="020F0502020204030204" pitchFamily="34" charset="0"/>
+                  <a:ea typeface="+mn-ea"/>
+                  <a:cs typeface="+mn-cs"/>
+                </a:defRPr>
+              </a:lvl2pPr>
+              <a:lvl3pPr marL="1143000" indent="-228600" algn="l" rtl="0" eaLnBrk="0" fontAlgn="base" hangingPunct="0">
+                <a:spcBef>
+                  <a:spcPct val="0"/>
+                </a:spcBef>
+                <a:spcAft>
+                  <a:spcPct val="0"/>
+                </a:spcAft>
+                <a:defRPr kern="1200">
+                  <a:solidFill>
+                    <a:schemeClr val="tx1"/>
+                  </a:solidFill>
+                  <a:latin typeface="Calibri" panose="020F0502020204030204" pitchFamily="34" charset="0"/>
+                  <a:ea typeface="+mn-ea"/>
+                  <a:cs typeface="+mn-cs"/>
+                </a:defRPr>
+              </a:lvl3pPr>
+              <a:lvl4pPr marL="1600200" indent="-228600" algn="l" rtl="0" eaLnBrk="0" fontAlgn="base" hangingPunct="0">
+                <a:spcBef>
+                  <a:spcPct val="0"/>
+                </a:spcBef>
+                <a:spcAft>
+                  <a:spcPct val="0"/>
+                </a:spcAft>
+                <a:defRPr kern="1200">
+                  <a:solidFill>
+                    <a:schemeClr val="tx1"/>
+                  </a:solidFill>
+                  <a:latin typeface="Calibri" panose="020F0502020204030204" pitchFamily="34" charset="0"/>
+                  <a:ea typeface="+mn-ea"/>
+                  <a:cs typeface="+mn-cs"/>
+                </a:defRPr>
+              </a:lvl4pPr>
+              <a:lvl5pPr marL="2057400" indent="-228600" algn="l" rtl="0" eaLnBrk="0" fontAlgn="base" hangingPunct="0">
+                <a:spcBef>
+                  <a:spcPct val="0"/>
+                </a:spcBef>
+                <a:spcAft>
+                  <a:spcPct val="0"/>
+                </a:spcAft>
+                <a:defRPr kern="1200">
+                  <a:solidFill>
+                    <a:schemeClr val="tx1"/>
+                  </a:solidFill>
+                  <a:latin typeface="Calibri" panose="020F0502020204030204" pitchFamily="34" charset="0"/>
+                  <a:ea typeface="+mn-ea"/>
+                  <a:cs typeface="+mn-cs"/>
+                </a:defRPr>
+              </a:lvl5pPr>
+              <a:lvl6pPr marL="2514600" indent="-228600" algn="l" defTabSz="914400" rtl="0" eaLnBrk="0" fontAlgn="base" latinLnBrk="0" hangingPunct="0">
+                <a:spcBef>
+                  <a:spcPct val="0"/>
+                </a:spcBef>
+                <a:spcAft>
+                  <a:spcPct val="0"/>
+                </a:spcAft>
+                <a:defRPr kern="1200">
+                  <a:solidFill>
+                    <a:schemeClr val="tx1"/>
+                  </a:solidFill>
+                  <a:latin typeface="Calibri" panose="020F0502020204030204" pitchFamily="34" charset="0"/>
+                  <a:ea typeface="+mn-ea"/>
+                  <a:cs typeface="+mn-cs"/>
+                </a:defRPr>
+              </a:lvl6pPr>
+              <a:lvl7pPr marL="2971800" indent="-228600" algn="l" defTabSz="914400" rtl="0" eaLnBrk="0" fontAlgn="base" latinLnBrk="0" hangingPunct="0">
+                <a:spcBef>
+                  <a:spcPct val="0"/>
+                </a:spcBef>
+                <a:spcAft>
+                  <a:spcPct val="0"/>
+                </a:spcAft>
+                <a:defRPr kern="1200">
+                  <a:solidFill>
+                    <a:schemeClr val="tx1"/>
+                  </a:solidFill>
+                  <a:latin typeface="Calibri" panose="020F0502020204030204" pitchFamily="34" charset="0"/>
+                  <a:ea typeface="+mn-ea"/>
+                  <a:cs typeface="+mn-cs"/>
+                </a:defRPr>
+              </a:lvl7pPr>
+              <a:lvl8pPr marL="3429000" indent="-228600" algn="l" defTabSz="914400" rtl="0" eaLnBrk="0" fontAlgn="base" latinLnBrk="0" hangingPunct="0">
+                <a:spcBef>
+                  <a:spcPct val="0"/>
+                </a:spcBef>
+                <a:spcAft>
+                  <a:spcPct val="0"/>
+                </a:spcAft>
+                <a:defRPr kern="1200">
+                  <a:solidFill>
+                    <a:schemeClr val="tx1"/>
+                  </a:solidFill>
+                  <a:latin typeface="Calibri" panose="020F0502020204030204" pitchFamily="34" charset="0"/>
+                  <a:ea typeface="+mn-ea"/>
+                  <a:cs typeface="+mn-cs"/>
+                </a:defRPr>
+              </a:lvl8pPr>
+              <a:lvl9pPr marL="3886200" indent="-228600" algn="l" defTabSz="914400" rtl="0" eaLnBrk="0" fontAlgn="base" latinLnBrk="0" hangingPunct="0">
+                <a:spcBef>
+                  <a:spcPct val="0"/>
+                </a:spcBef>
+                <a:spcAft>
+                  <a:spcPct val="0"/>
+                </a:spcAft>
+                <a:defRPr kern="1200">
+                  <a:solidFill>
+                    <a:schemeClr val="tx1"/>
+                  </a:solidFill>
+                  <a:latin typeface="Calibri" panose="020F0502020204030204" pitchFamily="34" charset="0"/>
+                  <a:ea typeface="+mn-ea"/>
+                  <a:cs typeface="+mn-cs"/>
+                </a:defRPr>
+              </a:lvl9pPr>
+            </a:lstStyle>
+            <a:p>
+              <a:pPr algn="ctr" eaLnBrk="1" hangingPunct="1"/>
+              <a:r>
+                <a:rPr lang="en-US" altLang="en-US" sz="800" dirty="0" err="1">
                   <a:latin typeface="Arial" panose="020B0604020202020204" pitchFamily="34" charset="0"/>
                   <a:ea typeface="Amazon Ember" panose="020B0603020204020204" pitchFamily="34" charset="0"/>
                   <a:cs typeface="Arial" panose="020B0604020202020204" pitchFamily="34" charset="0"/>
-                </a:endParaRPr>
-              </a:p>
-            </p:txBody>
-          </p:sp>
-        </p:grpSp>
+                </a:rPr>
+                <a:t>UploadUrlLambdaServiceRole</a:t>
+              </a:r>
+              <a:endParaRPr lang="en-US" altLang="en-US" sz="800" dirty="0">
+                <a:latin typeface="Arial" panose="020B0604020202020204" pitchFamily="34" charset="0"/>
+                <a:ea typeface="Amazon Ember" panose="020B0603020204020204" pitchFamily="34" charset="0"/>
+                <a:cs typeface="Arial" panose="020B0604020202020204" pitchFamily="34" charset="0"/>
+              </a:endParaRPr>
+            </a:p>
+          </p:txBody>
+        </p:sp>
       </p:grpSp>
       <p:grpSp>
         <p:nvGrpSpPr>
@@ -7613,10 +7592,10 @@
               <p:nvPr/>
             </p:nvPicPr>
             <p:blipFill>
-              <a:blip r:embed="rId15">
+              <a:blip r:embed="rId16">
                 <a:extLst>
                   <a:ext uri="{96DAC541-7B7A-43D3-8B79-37D633B846F1}">
-                    <asvg:svgBlip xmlns:asvg="http://schemas.microsoft.com/office/drawing/2016/SVG/main" r:embed="rId16"/>
+                    <asvg:svgBlip xmlns:asvg="http://schemas.microsoft.com/office/drawing/2016/SVG/main" r:embed="rId17"/>
                   </a:ext>
                 </a:extLst>
               </a:blip>
@@ -8114,10 +8093,10 @@
             <p:nvPr/>
           </p:nvPicPr>
           <p:blipFill>
-            <a:blip r:embed="rId17">
+            <a:blip r:embed="rId18">
               <a:extLst>
                 <a:ext uri="{96DAC541-7B7A-43D3-8B79-37D633B846F1}">
-                  <asvg:svgBlip xmlns:asvg="http://schemas.microsoft.com/office/drawing/2016/SVG/main" r:embed="rId18"/>
+                  <asvg:svgBlip xmlns:asvg="http://schemas.microsoft.com/office/drawing/2016/SVG/main" r:embed="rId19"/>
                 </a:ext>
               </a:extLst>
             </a:blip>
@@ -8169,10 +8148,10 @@
               <p:nvPr/>
             </p:nvPicPr>
             <p:blipFill>
-              <a:blip r:embed="rId15">
+              <a:blip r:embed="rId16">
                 <a:extLst>
                   <a:ext uri="{96DAC541-7B7A-43D3-8B79-37D633B846F1}">
-                    <asvg:svgBlip xmlns:asvg="http://schemas.microsoft.com/office/drawing/2016/SVG/main" r:embed="rId16"/>
+                    <asvg:svgBlip xmlns:asvg="http://schemas.microsoft.com/office/drawing/2016/SVG/main" r:embed="rId17"/>
                   </a:ext>
                 </a:extLst>
               </a:blip>
@@ -8457,10 +8436,10 @@
           <p:nvPr/>
         </p:nvPicPr>
         <p:blipFill>
-          <a:blip r:embed="rId19">
+          <a:blip r:embed="rId20">
             <a:extLst>
               <a:ext uri="{96DAC541-7B7A-43D3-8B79-37D633B846F1}">
-                <asvg:svgBlip xmlns:asvg="http://schemas.microsoft.com/office/drawing/2016/SVG/main" r:embed="rId20"/>
+                <asvg:svgBlip xmlns:asvg="http://schemas.microsoft.com/office/drawing/2016/SVG/main" r:embed="rId21"/>
               </a:ext>
             </a:extLst>
           </a:blip>
@@ -8726,10 +8705,10 @@
           <p:nvPr/>
         </p:nvPicPr>
         <p:blipFill>
-          <a:blip r:embed="rId21">
+          <a:blip r:embed="rId22">
             <a:extLst>
               <a:ext uri="{96DAC541-7B7A-43D3-8B79-37D633B846F1}">
-                <asvg:svgBlip xmlns:asvg="http://schemas.microsoft.com/office/drawing/2016/SVG/main" r:embed="rId22"/>
+                <asvg:svgBlip xmlns:asvg="http://schemas.microsoft.com/office/drawing/2016/SVG/main" r:embed="rId23"/>
               </a:ext>
             </a:extLst>
           </a:blip>

</xml_diff>